<commit_message>
flowchart revision, file cleanup
</commit_message>
<xml_diff>
--- a/flowchart1.pptx
+++ b/flowchart1.pptx
@@ -3915,49 +3915,6 @@
       </p:sp>
       <p:sp>
         <p:nvSpPr>
-          <p:cNvPr id="11" name="TextBox 10">
-            <a:extLst>
-              <a:ext uri="{FF2B5EF4-FFF2-40B4-BE49-F238E27FC236}">
-                <a16:creationId xmlns:a16="http://schemas.microsoft.com/office/drawing/2014/main" id="{DB0BFDA7-B055-A5DC-BE10-7870FF5E73CA}"/>
-              </a:ext>
-            </a:extLst>
-          </p:cNvPr>
-          <p:cNvSpPr txBox="1"/>
-          <p:nvPr/>
-        </p:nvSpPr>
-        <p:spPr>
-          <a:xfrm>
-            <a:off x="5945610" y="5543328"/>
-            <a:ext cx="2538580" cy="523220"/>
-          </a:xfrm>
-          <a:prstGeom prst="rect">
-            <a:avLst/>
-          </a:prstGeom>
-          <a:noFill/>
-          <a:ln>
-            <a:solidFill>
-              <a:schemeClr val="accent1"/>
-            </a:solidFill>
-          </a:ln>
-        </p:spPr>
-        <p:txBody>
-          <a:bodyPr wrap="none" rtlCol="0">
-            <a:spAutoFit/>
-          </a:bodyPr>
-          <a:lstStyle/>
-          <a:p>
-            <a:r>
-              <a:rPr lang="en-US" sz="2800" i="1" dirty="0">
-                <a:latin typeface="Times New Roman" panose="02020603050405020304" pitchFamily="18" charset="0"/>
-                <a:cs typeface="Times New Roman" panose="02020603050405020304" pitchFamily="18" charset="0"/>
-              </a:rPr>
-              <a:t>Weight ~ Length</a:t>
-            </a:r>
-          </a:p>
-        </p:txBody>
-      </p:sp>
-      <p:sp>
-        <p:nvSpPr>
           <p:cNvPr id="12" name="TextBox 11">
             <a:extLst>
               <a:ext uri="{FF2B5EF4-FFF2-40B4-BE49-F238E27FC236}">
@@ -4476,10 +4433,10 @@
         </p:nvGrpSpPr>
         <p:grpSpPr>
           <a:xfrm>
-            <a:off x="4058236" y="1442446"/>
-            <a:ext cx="1316409" cy="639199"/>
-            <a:chOff x="4436551" y="1954668"/>
-            <a:chExt cx="975523" cy="450062"/>
+            <a:off x="4058236" y="1446876"/>
+            <a:ext cx="1316409" cy="597983"/>
+            <a:chOff x="4436551" y="1957784"/>
+            <a:chExt cx="975523" cy="421041"/>
           </a:xfrm>
         </p:grpSpPr>
         <p:sp>
@@ -4496,8 +4453,8 @@
           </p:nvSpPr>
           <p:spPr>
             <a:xfrm>
-              <a:off x="4603780" y="1954668"/>
-              <a:ext cx="579935" cy="450062"/>
+              <a:off x="4590419" y="1957784"/>
+              <a:ext cx="683282" cy="368401"/>
             </a:xfrm>
             <a:prstGeom prst="rect">
               <a:avLst/>
@@ -4515,7 +4472,7 @@
                   <a:latin typeface="Times New Roman" panose="02020603050405020304" pitchFamily="18" charset="0"/>
                   <a:cs typeface="Times New Roman" panose="02020603050405020304" pitchFamily="18" charset="0"/>
                 </a:rPr>
-                <a:t>Age</a:t>
+                <a:t>Ages</a:t>
               </a:r>
             </a:p>
           </p:txBody>
@@ -4585,10 +4542,10 @@
         </p:nvGrpSpPr>
         <p:grpSpPr>
           <a:xfrm>
-            <a:off x="5402734" y="469642"/>
-            <a:ext cx="1712271" cy="611570"/>
+            <a:off x="5402734" y="469644"/>
+            <a:ext cx="1712271" cy="611569"/>
             <a:chOff x="5499196" y="1966906"/>
-            <a:chExt cx="1226325" cy="421042"/>
+            <a:chExt cx="1226325" cy="421041"/>
           </a:xfrm>
         </p:grpSpPr>
         <p:sp>
@@ -4605,8 +4562,8 @@
           </p:nvSpPr>
           <p:spPr>
             <a:xfrm>
-              <a:off x="5685484" y="1977489"/>
-              <a:ext cx="1005804" cy="410459"/>
+              <a:off x="5645637" y="1983890"/>
+              <a:ext cx="960015" cy="360216"/>
             </a:xfrm>
             <a:prstGeom prst="rect">
               <a:avLst/>
@@ -4624,7 +4581,7 @@
                   <a:latin typeface="Times New Roman" panose="02020603050405020304" pitchFamily="18" charset="0"/>
                   <a:cs typeface="Times New Roman" panose="02020603050405020304" pitchFamily="18" charset="0"/>
                 </a:rPr>
-                <a:t>Length</a:t>
+                <a:t>Lengths</a:t>
               </a:r>
             </a:p>
           </p:txBody>
@@ -4694,10 +4651,10 @@
         </p:nvGrpSpPr>
         <p:grpSpPr>
           <a:xfrm>
-            <a:off x="7639530" y="463073"/>
-            <a:ext cx="1712271" cy="627387"/>
+            <a:off x="7639530" y="463074"/>
+            <a:ext cx="1712271" cy="620502"/>
             <a:chOff x="6831373" y="2020000"/>
-            <a:chExt cx="1398910" cy="425713"/>
+            <a:chExt cx="1398910" cy="421041"/>
           </a:xfrm>
         </p:grpSpPr>
         <p:sp>
@@ -4714,8 +4671,8 @@
           </p:nvSpPr>
           <p:spPr>
             <a:xfrm>
-              <a:off x="7045796" y="2028614"/>
-              <a:ext cx="906853" cy="417099"/>
+              <a:off x="7021711" y="2038839"/>
+              <a:ext cx="1103083" cy="355031"/>
             </a:xfrm>
             <a:prstGeom prst="rect">
               <a:avLst/>
@@ -4733,7 +4690,7 @@
                   <a:latin typeface="Times New Roman" panose="02020603050405020304" pitchFamily="18" charset="0"/>
                   <a:cs typeface="Times New Roman" panose="02020603050405020304" pitchFamily="18" charset="0"/>
                 </a:rPr>
-                <a:t>Weight</a:t>
+                <a:t>Weights</a:t>
               </a:r>
             </a:p>
           </p:txBody>
@@ -4900,70 +4857,22 @@
       </p:grpSp>
       <p:cxnSp>
         <p:nvCxnSpPr>
-          <p:cNvPr id="48" name="Straight Arrow Connector 47">
-            <a:extLst>
-              <a:ext uri="{FF2B5EF4-FFF2-40B4-BE49-F238E27FC236}">
-                <a16:creationId xmlns:a16="http://schemas.microsoft.com/office/drawing/2014/main" id="{29F410FB-BE61-C6CB-4DC4-83385753C295}"/>
+          <p:cNvPr id="50" name="Straight Arrow Connector 49">
+            <a:extLst>
+              <a:ext uri="{FF2B5EF4-FFF2-40B4-BE49-F238E27FC236}">
+                <a16:creationId xmlns:a16="http://schemas.microsoft.com/office/drawing/2014/main" id="{8C4F8F3B-7B8E-EF57-E14B-E31E993AFD49}"/>
               </a:ext>
             </a:extLst>
           </p:cNvPr>
           <p:cNvCxnSpPr>
             <a:cxnSpLocks/>
-            <a:stCxn id="11" idx="1"/>
-            <a:endCxn id="17" idx="6"/>
-          </p:cNvCxnSpPr>
-          <p:nvPr/>
-        </p:nvCxnSpPr>
-        <p:spPr>
-          <a:xfrm flipH="1" flipV="1">
-            <a:off x="4823942" y="5799012"/>
-            <a:ext cx="1121668" cy="5926"/>
-          </a:xfrm>
-          <a:prstGeom prst="straightConnector1">
-            <a:avLst/>
-          </a:prstGeom>
-          <a:ln w="31750">
-            <a:solidFill>
-              <a:schemeClr val="tx1"/>
-            </a:solidFill>
-            <a:tailEnd type="triangle"/>
-          </a:ln>
-        </p:spPr>
-        <p:style>
-          <a:lnRef idx="2">
-            <a:schemeClr val="accent1"/>
-          </a:lnRef>
-          <a:fillRef idx="0">
-            <a:schemeClr val="accent1"/>
-          </a:fillRef>
-          <a:effectRef idx="1">
-            <a:schemeClr val="accent1"/>
-          </a:effectRef>
-          <a:fontRef idx="minor">
-            <a:schemeClr val="tx1"/>
-          </a:fontRef>
-        </p:style>
-      </p:cxnSp>
-      <p:cxnSp>
-        <p:nvCxnSpPr>
-          <p:cNvPr id="50" name="Straight Arrow Connector 49">
-            <a:extLst>
-              <a:ext uri="{FF2B5EF4-FFF2-40B4-BE49-F238E27FC236}">
-                <a16:creationId xmlns:a16="http://schemas.microsoft.com/office/drawing/2014/main" id="{8C4F8F3B-7B8E-EF57-E14B-E31E993AFD49}"/>
-              </a:ext>
-            </a:extLst>
-          </p:cNvPr>
-          <p:cNvCxnSpPr>
-            <a:cxnSpLocks/>
-            <a:stCxn id="11" idx="3"/>
-            <a:endCxn id="18" idx="2"/>
           </p:cNvCxnSpPr>
           <p:nvPr/>
         </p:nvCxnSpPr>
         <p:spPr>
           <a:xfrm>
-            <a:off x="8484190" y="5804938"/>
-            <a:ext cx="471249" cy="291"/>
+            <a:off x="4794618" y="5676900"/>
+            <a:ext cx="4217358" cy="0"/>
           </a:xfrm>
           <a:prstGeom prst="straightConnector1">
             <a:avLst/>
@@ -5790,6 +5699,95 @@
           </a:fontRef>
         </p:style>
       </p:cxnSp>
+      <p:cxnSp>
+        <p:nvCxnSpPr>
+          <p:cNvPr id="48" name="Straight Arrow Connector 47">
+            <a:extLst>
+              <a:ext uri="{FF2B5EF4-FFF2-40B4-BE49-F238E27FC236}">
+                <a16:creationId xmlns:a16="http://schemas.microsoft.com/office/drawing/2014/main" id="{29F410FB-BE61-C6CB-4DC4-83385753C295}"/>
+              </a:ext>
+            </a:extLst>
+          </p:cNvPr>
+          <p:cNvCxnSpPr>
+            <a:cxnSpLocks/>
+          </p:cNvCxnSpPr>
+          <p:nvPr/>
+        </p:nvCxnSpPr>
+        <p:spPr>
+          <a:xfrm flipH="1">
+            <a:off x="4794618" y="5909683"/>
+            <a:ext cx="4160821" cy="0"/>
+          </a:xfrm>
+          <a:prstGeom prst="straightConnector1">
+            <a:avLst/>
+          </a:prstGeom>
+          <a:ln w="31750">
+            <a:solidFill>
+              <a:schemeClr val="tx1"/>
+            </a:solidFill>
+            <a:tailEnd type="triangle"/>
+          </a:ln>
+        </p:spPr>
+        <p:style>
+          <a:lnRef idx="2">
+            <a:schemeClr val="accent1"/>
+          </a:lnRef>
+          <a:fillRef idx="0">
+            <a:schemeClr val="accent1"/>
+          </a:fillRef>
+          <a:effectRef idx="1">
+            <a:schemeClr val="accent1"/>
+          </a:effectRef>
+          <a:fontRef idx="minor">
+            <a:schemeClr val="tx1"/>
+          </a:fontRef>
+        </p:style>
+      </p:cxnSp>
+      <p:sp>
+        <p:nvSpPr>
+          <p:cNvPr id="11" name="TextBox 10">
+            <a:extLst>
+              <a:ext uri="{FF2B5EF4-FFF2-40B4-BE49-F238E27FC236}">
+                <a16:creationId xmlns:a16="http://schemas.microsoft.com/office/drawing/2014/main" id="{DB0BFDA7-B055-A5DC-BE10-7870FF5E73CA}"/>
+              </a:ext>
+            </a:extLst>
+          </p:cNvPr>
+          <p:cNvSpPr txBox="1"/>
+          <p:nvPr/>
+        </p:nvSpPr>
+        <p:spPr>
+          <a:xfrm>
+            <a:off x="5945610" y="5543328"/>
+            <a:ext cx="2538580" cy="523220"/>
+          </a:xfrm>
+          <a:prstGeom prst="rect">
+            <a:avLst/>
+          </a:prstGeom>
+          <a:solidFill>
+            <a:schemeClr val="bg1"/>
+          </a:solidFill>
+          <a:ln>
+            <a:solidFill>
+              <a:schemeClr val="accent1"/>
+            </a:solidFill>
+          </a:ln>
+        </p:spPr>
+        <p:txBody>
+          <a:bodyPr wrap="none" rtlCol="0">
+            <a:spAutoFit/>
+          </a:bodyPr>
+          <a:lstStyle/>
+          <a:p>
+            <a:r>
+              <a:rPr lang="en-US" sz="2800" i="1" dirty="0">
+                <a:latin typeface="Times New Roman" panose="02020603050405020304" pitchFamily="18" charset="0"/>
+                <a:cs typeface="Times New Roman" panose="02020603050405020304" pitchFamily="18" charset="0"/>
+              </a:rPr>
+              <a:t>Weight ~ Length</a:t>
+            </a:r>
+          </a:p>
+        </p:txBody>
+      </p:sp>
     </p:spTree>
     <p:extLst>
       <p:ext uri="{BB962C8B-B14F-4D97-AF65-F5344CB8AC3E}">

</xml_diff>

<commit_message>
added references, flowchart fixes
</commit_message>
<xml_diff>
--- a/flowchart1.pptx
+++ b/flowchart1.pptx
@@ -197,7 +197,7 @@
           <a:p>
             <a:fld id="{278C10AC-A582-4B68-BB75-A8CE1667D471}" type="datetimeFigureOut">
               <a:rPr lang="en-US" smtClean="0"/>
-              <a:t>5/29/2026</a:t>
+              <a:t>6/2/2026</a:t>
             </a:fld>
             <a:endParaRPr lang="en-US"/>
           </a:p>
@@ -695,7 +695,7 @@
           <a:p>
             <a:fld id="{7BEBC745-84D4-4C06-A47B-54CB13756FAB}" type="datetimeFigureOut">
               <a:rPr lang="en-US" smtClean="0"/>
-              <a:t>5/29/2026</a:t>
+              <a:t>6/2/2026</a:t>
             </a:fld>
             <a:endParaRPr lang="en-US"/>
           </a:p>
@@ -893,7 +893,7 @@
           <a:p>
             <a:fld id="{7BEBC745-84D4-4C06-A47B-54CB13756FAB}" type="datetimeFigureOut">
               <a:rPr lang="en-US" smtClean="0"/>
-              <a:t>5/29/2026</a:t>
+              <a:t>6/2/2026</a:t>
             </a:fld>
             <a:endParaRPr lang="en-US"/>
           </a:p>
@@ -1101,7 +1101,7 @@
           <a:p>
             <a:fld id="{7BEBC745-84D4-4C06-A47B-54CB13756FAB}" type="datetimeFigureOut">
               <a:rPr lang="en-US" smtClean="0"/>
-              <a:t>5/29/2026</a:t>
+              <a:t>6/2/2026</a:t>
             </a:fld>
             <a:endParaRPr lang="en-US"/>
           </a:p>
@@ -1299,7 +1299,7 @@
           <a:p>
             <a:fld id="{7BEBC745-84D4-4C06-A47B-54CB13756FAB}" type="datetimeFigureOut">
               <a:rPr lang="en-US" smtClean="0"/>
-              <a:t>5/29/2026</a:t>
+              <a:t>6/2/2026</a:t>
             </a:fld>
             <a:endParaRPr lang="en-US"/>
           </a:p>
@@ -1574,7 +1574,7 @@
           <a:p>
             <a:fld id="{7BEBC745-84D4-4C06-A47B-54CB13756FAB}" type="datetimeFigureOut">
               <a:rPr lang="en-US" smtClean="0"/>
-              <a:t>5/29/2026</a:t>
+              <a:t>6/2/2026</a:t>
             </a:fld>
             <a:endParaRPr lang="en-US"/>
           </a:p>
@@ -1839,7 +1839,7 @@
           <a:p>
             <a:fld id="{7BEBC745-84D4-4C06-A47B-54CB13756FAB}" type="datetimeFigureOut">
               <a:rPr lang="en-US" smtClean="0"/>
-              <a:t>5/29/2026</a:t>
+              <a:t>6/2/2026</a:t>
             </a:fld>
             <a:endParaRPr lang="en-US"/>
           </a:p>
@@ -2251,7 +2251,7 @@
           <a:p>
             <a:fld id="{7BEBC745-84D4-4C06-A47B-54CB13756FAB}" type="datetimeFigureOut">
               <a:rPr lang="en-US" smtClean="0"/>
-              <a:t>5/29/2026</a:t>
+              <a:t>6/2/2026</a:t>
             </a:fld>
             <a:endParaRPr lang="en-US"/>
           </a:p>
@@ -2392,7 +2392,7 @@
           <a:p>
             <a:fld id="{7BEBC745-84D4-4C06-A47B-54CB13756FAB}" type="datetimeFigureOut">
               <a:rPr lang="en-US" smtClean="0"/>
-              <a:t>5/29/2026</a:t>
+              <a:t>6/2/2026</a:t>
             </a:fld>
             <a:endParaRPr lang="en-US"/>
           </a:p>
@@ -2505,7 +2505,7 @@
           <a:p>
             <a:fld id="{7BEBC745-84D4-4C06-A47B-54CB13756FAB}" type="datetimeFigureOut">
               <a:rPr lang="en-US" smtClean="0"/>
-              <a:t>5/29/2026</a:t>
+              <a:t>6/2/2026</a:t>
             </a:fld>
             <a:endParaRPr lang="en-US"/>
           </a:p>
@@ -2816,7 +2816,7 @@
           <a:p>
             <a:fld id="{7BEBC745-84D4-4C06-A47B-54CB13756FAB}" type="datetimeFigureOut">
               <a:rPr lang="en-US" smtClean="0"/>
-              <a:t>5/29/2026</a:t>
+              <a:t>6/2/2026</a:t>
             </a:fld>
             <a:endParaRPr lang="en-US"/>
           </a:p>
@@ -3104,7 +3104,7 @@
           <a:p>
             <a:fld id="{7BEBC745-84D4-4C06-A47B-54CB13756FAB}" type="datetimeFigureOut">
               <a:rPr lang="en-US" smtClean="0"/>
-              <a:t>5/29/2026</a:t>
+              <a:t>6/2/2026</a:t>
             </a:fld>
             <a:endParaRPr lang="en-US"/>
           </a:p>
@@ -3345,7 +3345,7 @@
           <a:p>
             <a:fld id="{7BEBC745-84D4-4C06-A47B-54CB13756FAB}" type="datetimeFigureOut">
               <a:rPr lang="en-US" smtClean="0"/>
-              <a:t>5/29/2026</a:t>
+              <a:t>6/2/2026</a:t>
             </a:fld>
             <a:endParaRPr lang="en-US"/>
           </a:p>
@@ -3776,8 +3776,8 @@
         </p:nvSpPr>
         <p:spPr>
           <a:xfrm>
-            <a:off x="8555205" y="4124204"/>
-            <a:ext cx="3464538" cy="523220"/>
+            <a:off x="8601385" y="4124204"/>
+            <a:ext cx="3335272" cy="523220"/>
           </a:xfrm>
           <a:prstGeom prst="rect">
             <a:avLst/>
@@ -3800,19 +3800,15 @@
                 <a:latin typeface="Times New Roman" panose="02020603050405020304" pitchFamily="18" charset="0"/>
                 <a:cs typeface="Times New Roman" panose="02020603050405020304" pitchFamily="18" charset="0"/>
               </a:rPr>
-              <a:t>Weight quantile ~ </a:t>
-            </a:r>
-            <a:r>
-              <a:rPr lang="en-US" sz="2800" i="1" dirty="0" err="1">
+              <a:t>Weight quantile ~ W</a:t>
+            </a:r>
+            <a:r>
+              <a:rPr lang="en-US" sz="2800" i="1" baseline="-25000" dirty="0">
                 <a:latin typeface="Times New Roman" panose="02020603050405020304" pitchFamily="18" charset="0"/>
                 <a:cs typeface="Times New Roman" panose="02020603050405020304" pitchFamily="18" charset="0"/>
               </a:rPr>
-              <a:t>Winf</a:t>
-            </a:r>
-            <a:endParaRPr lang="en-US" sz="2800" i="1" dirty="0">
-              <a:latin typeface="Times New Roman" panose="02020603050405020304" pitchFamily="18" charset="0"/>
-              <a:cs typeface="Times New Roman" panose="02020603050405020304" pitchFamily="18" charset="0"/>
-            </a:endParaRPr>
+              <a:t>∞</a:t>
+            </a:r>
           </a:p>
         </p:txBody>
       </p:sp>
@@ -3830,8 +3826,8 @@
         </p:nvSpPr>
         <p:spPr>
           <a:xfrm>
-            <a:off x="134473" y="4986760"/>
-            <a:ext cx="3387466" cy="523220"/>
+            <a:off x="263777" y="4986760"/>
+            <a:ext cx="3217547" cy="523220"/>
           </a:xfrm>
           <a:prstGeom prst="rect">
             <a:avLst/>
@@ -3854,19 +3850,15 @@
                 <a:latin typeface="Times New Roman" panose="02020603050405020304" pitchFamily="18" charset="0"/>
                 <a:cs typeface="Times New Roman" panose="02020603050405020304" pitchFamily="18" charset="0"/>
               </a:rPr>
-              <a:t> length quantile ~ </a:t>
-            </a:r>
-            <a:r>
-              <a:rPr lang="en-US" sz="2800" i="1" dirty="0" err="1">
+              <a:t> length quantile ~ L</a:t>
+            </a:r>
+            <a:r>
+              <a:rPr lang="en-US" sz="2800" i="1" baseline="-25000" dirty="0">
                 <a:latin typeface="Times New Roman" panose="02020603050405020304" pitchFamily="18" charset="0"/>
                 <a:cs typeface="Times New Roman" panose="02020603050405020304" pitchFamily="18" charset="0"/>
               </a:rPr>
-              <a:t>Linf</a:t>
-            </a:r>
-            <a:endParaRPr lang="en-US" sz="2800" i="1" dirty="0">
-              <a:latin typeface="Times New Roman" panose="02020603050405020304" pitchFamily="18" charset="0"/>
-              <a:cs typeface="Times New Roman" panose="02020603050405020304" pitchFamily="18" charset="0"/>
-            </a:endParaRPr>
+              <a:t>∞</a:t>
+            </a:r>
           </a:p>
         </p:txBody>
       </p:sp>
@@ -4924,6 +4916,9 @@
             <a:avLst/>
           </a:prstGeom>
           <a:ln w="31750">
+            <a:solidFill>
+              <a:schemeClr val="tx1"/>
+            </a:solidFill>
             <a:tailEnd type="triangle"/>
           </a:ln>
         </p:spPr>
@@ -4967,6 +4962,9 @@
             </a:avLst>
           </a:prstGeom>
           <a:ln w="31750">
+            <a:solidFill>
+              <a:schemeClr val="tx1"/>
+            </a:solidFill>
             <a:tailEnd type="triangle"/>
           </a:ln>
         </p:spPr>
@@ -5011,6 +5009,9 @@
             </a:avLst>
           </a:prstGeom>
           <a:ln w="31750">
+            <a:solidFill>
+              <a:schemeClr val="tx1"/>
+            </a:solidFill>
             <a:tailEnd type="triangle"/>
           </a:ln>
         </p:spPr>
@@ -5054,6 +5055,9 @@
             </a:avLst>
           </a:prstGeom>
           <a:ln w="31750">
+            <a:solidFill>
+              <a:schemeClr val="tx1"/>
+            </a:solidFill>
             <a:tailEnd type="triangle"/>
           </a:ln>
         </p:spPr>
@@ -5097,6 +5101,9 @@
             </a:avLst>
           </a:prstGeom>
           <a:ln w="31750">
+            <a:solidFill>
+              <a:schemeClr val="tx1"/>
+            </a:solidFill>
             <a:tailEnd type="triangle"/>
           </a:ln>
         </p:spPr>
@@ -5133,13 +5140,16 @@
         </p:nvCxnSpPr>
         <p:spPr>
           <a:xfrm rot="16200000" flipH="1">
-            <a:off x="2681976" y="4656210"/>
-            <a:ext cx="289032" cy="1996572"/>
+            <a:off x="2704148" y="4678383"/>
+            <a:ext cx="289032" cy="1952226"/>
           </a:xfrm>
           <a:prstGeom prst="bentConnector2">
             <a:avLst/>
           </a:prstGeom>
           <a:ln w="31750">
+            <a:solidFill>
+              <a:schemeClr val="tx1"/>
+            </a:solidFill>
             <a:tailEnd type="triangle"/>
           </a:ln>
         </p:spPr>
@@ -5176,13 +5186,16 @@
         </p:nvCxnSpPr>
         <p:spPr>
           <a:xfrm rot="5400000">
-            <a:off x="9513582" y="5031336"/>
-            <a:ext cx="1157805" cy="389980"/>
+            <a:off x="9504355" y="5040564"/>
+            <a:ext cx="1157807" cy="371527"/>
           </a:xfrm>
           <a:prstGeom prst="bentConnector2">
             <a:avLst/>
           </a:prstGeom>
           <a:ln w="31750">
+            <a:solidFill>
+              <a:schemeClr val="tx1"/>
+            </a:solidFill>
             <a:tailEnd type="triangle"/>
           </a:ln>
         </p:spPr>
@@ -5224,6 +5237,9 @@
             <a:avLst/>
           </a:prstGeom>
           <a:ln w="31750">
+            <a:solidFill>
+              <a:schemeClr val="tx1"/>
+            </a:solidFill>
             <a:tailEnd type="triangle"/>
           </a:ln>
         </p:spPr>
@@ -5266,6 +5282,9 @@
             <a:avLst/>
           </a:prstGeom>
           <a:ln w="31750">
+            <a:solidFill>
+              <a:schemeClr val="tx1"/>
+            </a:solidFill>
             <a:tailEnd type="triangle"/>
           </a:ln>
         </p:spPr>
@@ -5308,6 +5327,9 @@
             <a:avLst/>
           </a:prstGeom>
           <a:ln w="31750">
+            <a:solidFill>
+              <a:schemeClr val="tx1"/>
+            </a:solidFill>
             <a:tailEnd type="triangle"/>
           </a:ln>
         </p:spPr>
@@ -5536,9 +5558,9 @@
           <p:nvPr/>
         </p:nvCxnSpPr>
         <p:spPr>
-          <a:xfrm flipH="1">
-            <a:off x="1828206" y="2424864"/>
-            <a:ext cx="28111" cy="2561896"/>
+          <a:xfrm>
+            <a:off x="1872551" y="2403208"/>
+            <a:ext cx="0" cy="2583552"/>
           </a:xfrm>
           <a:prstGeom prst="straightConnector1">
             <a:avLst/>
@@ -5583,8 +5605,8 @@
         </p:nvCxnSpPr>
         <p:spPr>
           <a:xfrm>
-            <a:off x="10267644" y="2874847"/>
-            <a:ext cx="19830" cy="1249357"/>
+            <a:off x="10267643" y="2874847"/>
+            <a:ext cx="1378" cy="1249357"/>
           </a:xfrm>
           <a:prstGeom prst="straightConnector1">
             <a:avLst/>
@@ -5681,6 +5703,9 @@
             <a:avLst/>
           </a:prstGeom>
           <a:ln w="31750">
+            <a:solidFill>
+              <a:schemeClr val="tx1"/>
+            </a:solidFill>
             <a:tailEnd type="triangle"/>
           </a:ln>
         </p:spPr>

</xml_diff>